<commit_message>
Update Module 9 to describe the built Day 3 lab, not a future proposal
The lab in labs/day3/ now exists (Parts A-E authored and pushed), so
Module 9 no longer frames itself as previewing a hypothetical future
build. Renamed 'Future lab architecture' to 'Lab architecture' and
'Prerequisites for the future lab' to 'Lab prerequisites', updated all
notes/takeaways from proposed/future tense to present tense, and added
a note on the golden-cases slide flagging that the built lab implements
3 of the 4 listed cases (rejected write deferred, per
part_e_evaluate.py's docstring) so the slide and the real lab stay
consistent. Rebuilt the deck for this module only.

Co-authored-by: Copilot <223556219+Copilot@users.noreply.github.com>
</commit_message>
<xml_diff>
--- a/decks/day3/module-9-lab-kickoff.pptx
+++ b/decks/day3/module-9-lab-kickoff.pptx
@@ -509,7 +509,7 @@
           <a:p>
             <a:r>
               <a:rPr lang="en-US" dirty="0"/>
-              <a:t>• This module frames a proposed future lab. No Day 3 lab files are created in this change.
+              <a:t>• This module previews labs/day3/'s five parts before hands-on time. The lab is complete and ready to run.
 • GROUNDING SOURCE: https://learn.microsoft.com/en-us/agent-framework/concepts/agents/conversations/session?tabs=python
 • GROUNDING SOURCE: https://learn.microsoft.com/en-us/agent-framework/agents/structured-outputs?tabs=python
 • GROUNDING SOURCE: https://learn.microsoft.com/en-us/agent-framework/agents/evaluation?tabs=python</a:t>
@@ -600,7 +600,7 @@
           <a:p>
             <a:r>
               <a:rPr lang="en-US" dirty="0"/>
-              <a:t>• This sequence composes the day's primitives. It is a proposed lab flow only; the repository intentionally has no labs/day3 implementation yet.
+              <a:t>• This sequence composes the day's primitives and matches labs/day3/'s five parts exactly — each part is its own standalone agent, not one assistant extended across parts.
 • GROUNDING SOURCE: https://learn.microsoft.com/en-us/agent-framework/concepts/agents/conversations/session?tabs=python
 • GROUNDING SOURCE: https://learn.microsoft.com/en-us/agent-framework/agents/structured-outputs?tabs=python
 • GROUNDING SOURCE: https://learn.microsoft.com/en-us/agent-framework/agents/evaluation?tabs=python</a:t>
@@ -872,7 +872,7 @@
           <a:p>
             <a:r>
               <a:rPr lang="en-US" dirty="0"/>
-              <a:t>• Include positive read, positive write, and no-tool cases. Ground truth must include the consolidated tool plus action. Repeat enough to observe variation, then report the observed rate without inventing a universal threshold.
+              <a:t>• Include positive read, positive write, and no-tool cases. Ground truth must include the consolidated tool plus action. Repeat enough to observe variation, then report the observed rate without inventing a universal threshold. The built lab implements 3 of the 4 cases below — rejected write is deferred; see labs/day3/python/part_e_evaluate.py's module docstring for why.
 • GROUNDING SOURCE: https://learn.microsoft.com/en-us/agent-framework/agents/evaluation?tabs=python</a:t>
             </a:r>
             <a:endParaRPr lang="en-US" dirty="0"/>
@@ -961,7 +961,7 @@
           <a:p>
             <a:r>
               <a:rPr lang="en-US" dirty="0"/>
-              <a:t>• Do not claim setup has already happened. A future lab author must supply a dedicated Entra-backed Azure DevOps Services organization/project, Foundry project and judge deployment, least-privilege identity, and known work-item fixtures.
+              <a:t>• These are learner-provided, per labs/day3/README.md's Prerequisites and Azure DevOps setup sections — a dedicated Entra-backed Azure DevOps Services organization/project, Foundry project and judge deployment, least-privilege identity, and known work-item fixtures.
 • GROUNDING SOURCE: https://learn.microsoft.com/en-us/azure/devops/mcp-server/remote-mcp-server?view=azure-devops
 • GROUNDING SOURCE: https://learn.microsoft.com/en-us/agent-framework/agents/evaluation?tabs=python</a:t>
             </a:r>
@@ -1141,7 +1141,7 @@
           <a:p>
             <a:r>
               <a:rPr lang="en-US" dirty="0"/>
-              <a:t>• Close the core Day 3 live time here. Learners have all required primitives for the proposed future lab.
+              <a:t>• Close the core Day 3 live time here. Learners have all required primitives before starting labs/day3/'s Parts A-E.
 • GROUNDING SOURCE: https://learn.microsoft.com/en-us/agent-framework/agents/evaluation?tabs=python
 • GROUNDING SOURCE: https://learn.microsoft.com/en-us/azure/devops/mcp-server/remote-mcp-server?view=azure-devops</a:t>
             </a:r>
@@ -1627,7 +1627,7 @@
                 <a:ea typeface="Calibri" pitchFamily="34" charset="-122"/>
                 <a:cs typeface="Calibri" pitchFamily="34" charset="-120"/>
               </a:rPr>
-              <a:t>Frame a proposed lab that composes Day 3's primitives</a:t>
+              <a:t>Preview the lab you're about to build</a:t>
             </a:r>
             <a:endParaRPr lang="en-US" sz="1800" dirty="0"/>
           </a:p>
@@ -1864,7 +1864,7 @@
                 <a:ea typeface="Calibri" pitchFamily="34" charset="-122"/>
                 <a:cs typeface="Calibri" pitchFamily="34" charset="-120"/>
               </a:rPr>
-              <a:t>Future lab architecture</a:t>
+              <a:t>Lab architecture</a:t>
             </a:r>
             <a:endParaRPr lang="en-US" sz="2800" dirty="0"/>
           </a:p>
@@ -5104,7 +5104,7 @@
                 <a:ea typeface="Calibri" pitchFamily="34" charset="-122"/>
                 <a:cs typeface="Calibri" pitchFamily="34" charset="-120"/>
               </a:rPr>
-              <a:t>Prerequisites for the future lab</a:t>
+              <a:t>Lab prerequisites</a:t>
             </a:r>
             <a:endParaRPr lang="en-US" sz="2800" dirty="0"/>
           </a:p>
@@ -7562,7 +7562,7 @@
                 <a:ea typeface="Calibri" pitchFamily="34" charset="-122"/>
                 <a:cs typeface="Calibri" pitchFamily="34" charset="-120"/>
               </a:rPr>
-              <a:t>You treat the lab sequence as a proposed structure, not a completed lab.</a:t>
+              <a:t>You'll see this five-part structure again in labs/day3/, then work through it yourself.</a:t>
             </a:r>
             <a:endParaRPr lang="en-US" sz="1300" dirty="0"/>
           </a:p>
@@ -7812,7 +7812,7 @@
                 <a:ea typeface="Calibri" pitchFamily="34" charset="-122"/>
                 <a:cs typeface="Calibri" pitchFamily="34" charset="-120"/>
               </a:rPr>
-              <a:t>You confirm prerequisites — a dedicated Azure DevOps project, a Foundry evaluation project, and known work-item fixtures — before this proposed lab can be scaffolded.</a:t>
+              <a:t>You confirm prerequisites — a dedicated Azure DevOps project, a Foundry evaluation project, and known work-item fixtures — before you start the lab.</a:t>
             </a:r>
             <a:endParaRPr lang="en-US" sz="1300" dirty="0"/>
           </a:p>

</xml_diff>